<commit_message>
Finalize Week 1 team credits
</commit_message>
<xml_diff>
--- a/Term 1/Week 1/hackathon/Prompt-Coach-Hackathon-Deck.pptx
+++ b/Term 1/Week 1/hackathon/Prompt-Coach-Hackathon-Deck.pptx
@@ -2,20 +2,20 @@
 <file path=ppt/presentation.xml><?xml version="1.0" encoding="utf-8"?>
 <p:presentation xmlns:p="http://schemas.openxmlformats.org/presentationml/2006/main">
   <p:sldMasterIdLst>
-    <p:sldMasterId xmlns:r="http://schemas.openxmlformats.org/officeDocument/2006/relationships" id="2147483648" r:id="Re09a7b3dbaa64c1a"/>
+    <p:sldMasterId xmlns:r="http://schemas.openxmlformats.org/officeDocument/2006/relationships" id="2147483648" r:id="R26679f15acc849fd"/>
   </p:sldMasterIdLst>
   <p:notesMasterIdLst>
-    <p:notesMasterId xmlns:r="http://schemas.openxmlformats.org/officeDocument/2006/relationships" r:id="Rbd1711272d3b4ba1"/>
+    <p:notesMasterId xmlns:r="http://schemas.openxmlformats.org/officeDocument/2006/relationships" r:id="Rafee74e4cab24fe0"/>
   </p:notesMasterIdLst>
   <p:sldIdLst>
-    <p:sldId xmlns:r="http://schemas.openxmlformats.org/officeDocument/2006/relationships" id="256" r:id="Rab1ea6958d19447f"/>
-    <p:sldId xmlns:r="http://schemas.openxmlformats.org/officeDocument/2006/relationships" id="257" r:id="R7a4f7d3647654713"/>
-    <p:sldId xmlns:r="http://schemas.openxmlformats.org/officeDocument/2006/relationships" id="258" r:id="R0c0ad4df52d14a25"/>
-    <p:sldId xmlns:r="http://schemas.openxmlformats.org/officeDocument/2006/relationships" id="259" r:id="R8986fd6e09ca4095"/>
-    <p:sldId xmlns:r="http://schemas.openxmlformats.org/officeDocument/2006/relationships" id="260" r:id="Rbeb33d4f3c084493"/>
-    <p:sldId xmlns:r="http://schemas.openxmlformats.org/officeDocument/2006/relationships" id="261" r:id="Rc5f24264ffb3450f"/>
-    <p:sldId xmlns:r="http://schemas.openxmlformats.org/officeDocument/2006/relationships" id="262" r:id="Rd0b0c7f3becc4f95"/>
-    <p:sldId xmlns:r="http://schemas.openxmlformats.org/officeDocument/2006/relationships" id="263" r:id="Rb721486fdd344262"/>
+    <p:sldId xmlns:r="http://schemas.openxmlformats.org/officeDocument/2006/relationships" id="256" r:id="Rd37b9a0be68a4c07"/>
+    <p:sldId xmlns:r="http://schemas.openxmlformats.org/officeDocument/2006/relationships" id="257" r:id="R7cca02b46dec4dd4"/>
+    <p:sldId xmlns:r="http://schemas.openxmlformats.org/officeDocument/2006/relationships" id="258" r:id="R25757ef4cdc54e91"/>
+    <p:sldId xmlns:r="http://schemas.openxmlformats.org/officeDocument/2006/relationships" id="259" r:id="R9ab46d3430fa45c2"/>
+    <p:sldId xmlns:r="http://schemas.openxmlformats.org/officeDocument/2006/relationships" id="260" r:id="R738a4e9424054973"/>
+    <p:sldId xmlns:r="http://schemas.openxmlformats.org/officeDocument/2006/relationships" id="261" r:id="R9530eaaa95e345fc"/>
+    <p:sldId xmlns:r="http://schemas.openxmlformats.org/officeDocument/2006/relationships" id="262" r:id="R6cc8505d75f94450"/>
+    <p:sldId xmlns:r="http://schemas.openxmlformats.org/officeDocument/2006/relationships" id="263" r:id="Rab5c3ecbf57046ef"/>
   </p:sldIdLst>
   <p:sldSz cx="12192000" cy="6858000"/>
   <p:notesSz cx="6858000" cy="9144000"/>
@@ -729,7 +729,7 @@
           <a:lstStyle xmlns:a="http://schemas.openxmlformats.org/drawingml/2006/main"/>
           <a:p xmlns:a="http://schemas.openxmlformats.org/drawingml/2006/main">
             <a:r>
-              <a:t>These are captures from the connected Lovable preview. The demo uses the draft 'Help me learn Python' and a revision that specifies while loops, learner level, plain English, one short example and a practice question without the answer. The full animated capture is stored in the Week 1 hackathon demo folder.</a:t>
+              <a:t>These captures come from the connected Lovable preview. The demo starts with the draft 'Help me learn Python' and shows the coach's example revision, the learner's own revision and the final comparison. The complete 57-second screen recording is stored in the Week 1 hackathon demo folder.</a:t>
             </a:r>
           </a:p>
         </p:txBody>
@@ -939,7 +939,7 @@
           <a:lstStyle xmlns:a="http://schemas.openxmlformats.org/drawingml/2006/main"/>
           <a:p xmlns:a="http://schemas.openxmlformats.org/drawingml/2006/main">
             <a:r>
-              <a:t>Suggested demo: click Try an example, request feedback, explain one missing dimension, paste the prepared revision, and compare. The captured GIF is a backup if the live AI service is slow. End by stating that the learner did the revision and the coach never answered the homework question.</a:t>
+              <a:t>Suggested live demo: click Try an example, request feedback, explain one missing dimension, write the revision and compare both drafts. The included 57-second screen recording is the backup if the live AI service is slow. End by stating that the learner wrote the revision and the coach never answered the homework question.</a:t>
             </a:r>
           </a:p>
         </p:txBody>
@@ -1007,7 +1007,7 @@
   </p:cSld>
   <p:clrMap bg1="lt1" tx1="dk1" bg2="lt2" tx2="dk2" accent1="accent1" accent2="accent2" accent3="accent3" accent4="accent4" accent5="accent5" accent6="accent6" hlink="hlink" folHlink="folHlink"/>
   <p:sldLayoutIdLst>
-    <p:sldLayoutId xmlns:r="http://schemas.openxmlformats.org/officeDocument/2006/relationships" id="2147483649" r:id="R263ae49c50c04b4c"/>
+    <p:sldLayoutId xmlns:r="http://schemas.openxmlformats.org/officeDocument/2006/relationships" id="2147483649" r:id="Ra3049fcec3904fc3"/>
   </p:sldLayoutIdLst>
   <p:txStyles>
     <p:titleStyle>
@@ -1819,7 +1819,7 @@
                 <a:ea typeface="Helvetica Neue"/>
                 <a:cs typeface="Helvetica Neue"/>
               </a:rPr>
-              <a:t>Max Lopez  ·  Lovable  ·  UN SDG 4 Quality Education</a:t>
+              <a:t>Max Lopez + Benjamin van Teeseling  ·  Lovable  ·  UN SDG 4</a:t>
             </a:r>
           </a:p>
         </p:txBody>
@@ -4679,7 +4679,7 @@
           <p:nvPr/>
         </p:nvPicPr>
         <p:blipFill>
-          <a:blip xmlns:r="http://schemas.openxmlformats.org/officeDocument/2006/relationships" xmlns:a="http://schemas.openxmlformats.org/drawingml/2006/main" r:embed="Rf1ee5c67243b4e5a"/>
+          <a:blip xmlns:r="http://schemas.openxmlformats.org/officeDocument/2006/relationships" xmlns:a="http://schemas.openxmlformats.org/drawingml/2006/main" r:embed="R5617621f02d044d0"/>
           <a:srcRect xmlns:a="http://schemas.openxmlformats.org/drawingml/2006/main" l="0" t="9222" r="0" b="9222"/>
           <a:stretch xmlns:a="http://schemas.openxmlformats.org/drawingml/2006/main">
             <a:fillRect l="0" t="0" r="0" b="0"/>
@@ -5101,7 +5101,7 @@
           <p:nvPr/>
         </p:nvPicPr>
         <p:blipFill>
-          <a:blip xmlns:r="http://schemas.openxmlformats.org/officeDocument/2006/relationships" xmlns:a="http://schemas.openxmlformats.org/drawingml/2006/main" r:embed="R77d4152dc99f4e9a"/>
+          <a:blip xmlns:r="http://schemas.openxmlformats.org/officeDocument/2006/relationships" xmlns:a="http://schemas.openxmlformats.org/drawingml/2006/main" r:embed="R4fffd0cbec704241"/>
           <a:srcRect xmlns:a="http://schemas.openxmlformats.org/drawingml/2006/main" l="0" t="7042" r="0" b="7042"/>
           <a:stretch xmlns:a="http://schemas.openxmlformats.org/drawingml/2006/main">
             <a:fillRect l="0" t="0" r="0" b="0"/>
@@ -5128,7 +5128,7 @@
           <p:nvPr/>
         </p:nvPicPr>
         <p:blipFill>
-          <a:blip xmlns:r="http://schemas.openxmlformats.org/officeDocument/2006/relationships" xmlns:a="http://schemas.openxmlformats.org/drawingml/2006/main" r:embed="R2c68fd0d105047fe"/>
+          <a:blip xmlns:r="http://schemas.openxmlformats.org/officeDocument/2006/relationships" xmlns:a="http://schemas.openxmlformats.org/drawingml/2006/main" r:embed="R09178050814e45d2"/>
           <a:srcRect xmlns:a="http://schemas.openxmlformats.org/drawingml/2006/main" l="0" t="9193" r="0" b="9193"/>
           <a:stretch xmlns:a="http://schemas.openxmlformats.org/drawingml/2006/main">
             <a:fillRect l="0" t="0" r="0" b="0"/>
@@ -7462,7 +7462,7 @@
                 <a:latin typeface="Helvetica Neue"/>
                 <a:ea typeface="Helvetica Neue"/>
                 <a:cs typeface="Helvetica Neue"/>
-                <a:hlinkClick xmlns:r="http://schemas.openxmlformats.org/officeDocument/2006/relationships" r:id="R3d902ca995fc490c"/>
+                <a:hlinkClick xmlns:r="http://schemas.openxmlformats.org/officeDocument/2006/relationships" r:id="Rb89c27c925be494d"/>
               </a:rPr>
               <a:t>github.com/Maxlopez02/ai4g-portfolio-MaxLopez</a:t>
             </a:r>

</xml_diff>